<commit_message>
docs: drop brand names from public copy and point home to localhost
GitHub About, README, and package description now say 線上簽核系統
and use http://127.0.0.1:3847 as the homepage.
</commit_message>
<xml_diff>
--- a/docs/線上簽核系統_操作手冊.pptx
+++ b/docs/線上簽核系統_操作手冊.pptx
@@ -2017,7 +2017,7 @@
                 <a:ea typeface="Microsoft JhengHei" pitchFamily="34" charset="-122"/>
                 <a:cs typeface="Microsoft JhengHei" pitchFamily="34" charset="-120"/>
               </a:rPr>
-              <a:t>正式站  https://192.168.99.220:3848   或   https://catshome.tw:3848</a:t>
+              <a:t>本機  http://127.0.0.1:3847</a:t>
             </a:r>
             <a:endParaRPr lang="en-US" sz="1400" dirty="0"/>
           </a:p>
@@ -2254,7 +2254,7 @@
                 <a:ea typeface="Microsoft JhengHei" pitchFamily="34" charset="-122"/>
                 <a:cs typeface="Microsoft JhengHei" pitchFamily="34" charset="-120"/>
               </a:rPr>
-              <a:t>CatsHome 線上簽核  ·  10 / 12</a:t>
+              <a:t>線上簽核系統  ·  10 / 12</a:t>
             </a:r>
             <a:endParaRPr lang="en-US" sz="1100" dirty="0"/>
           </a:p>
@@ -2904,7 +2904,7 @@
                 <a:ea typeface="Microsoft JhengHei" pitchFamily="34" charset="-122"/>
                 <a:cs typeface="Microsoft JhengHei" pitchFamily="34" charset="-120"/>
               </a:rPr>
-              <a:t>CatsHome 線上簽核  ·  11 / 12</a:t>
+              <a:t>線上簽核系統  ·  11 / 12</a:t>
             </a:r>
             <a:endParaRPr lang="en-US" sz="1100" dirty="0"/>
           </a:p>
@@ -3384,7 +3384,7 @@
                           <a:ea typeface="Microsoft JhengHei" pitchFamily="34" charset="-122"/>
                           <a:cs typeface="Microsoft JhengHei" pitchFamily="34" charset="-120"/>
                         </a:rPr>
-                        <a:t>區網 HTTPS</a:t>
+                        <a:t>本機（首頁）</a:t>
                       </a:r>
                       <a:endParaRPr lang="en-US" sz="1500" dirty="0">
                         <a:latin typeface="Microsoft JhengHei" charset="0"/>
@@ -3449,7 +3449,7 @@
                           <a:ea typeface="Microsoft JhengHei" pitchFamily="34" charset="-122"/>
                           <a:cs typeface="Microsoft JhengHei" pitchFamily="34" charset="-120"/>
                         </a:rPr>
-                        <a:t>https://192.168.99.220:3848</a:t>
+                        <a:t>http://127.0.0.1:3847</a:t>
                       </a:r>
                       <a:endParaRPr lang="en-US" sz="1500" dirty="0">
                         <a:latin typeface="Microsoft JhengHei" charset="0"/>
@@ -3516,7 +3516,7 @@
                           <a:ea typeface="Microsoft JhengHei" pitchFamily="34" charset="-122"/>
                           <a:cs typeface="Microsoft JhengHei" pitchFamily="34" charset="-120"/>
                         </a:rPr>
-                        <a:t>網域 HTTPS</a:t>
+                        <a:t>區網 HTTP</a:t>
                       </a:r>
                       <a:endParaRPr lang="en-US" sz="1500" dirty="0">
                         <a:latin typeface="Microsoft JhengHei" charset="0"/>
@@ -3581,7 +3581,7 @@
                           <a:ea typeface="Microsoft JhengHei" pitchFamily="34" charset="-122"/>
                           <a:cs typeface="Microsoft JhengHei" pitchFamily="34" charset="-120"/>
                         </a:rPr>
-                        <a:t>https://catshome.tw:3848</a:t>
+                        <a:t>http://伺服器IP:3847</a:t>
                       </a:r>
                       <a:endParaRPr lang="en-US" sz="1500" dirty="0">
                         <a:latin typeface="Microsoft JhengHei" charset="0"/>
@@ -3648,7 +3648,7 @@
                           <a:ea typeface="Microsoft JhengHei" pitchFamily="34" charset="-122"/>
                           <a:cs typeface="Microsoft JhengHei" pitchFamily="34" charset="-120"/>
                         </a:rPr>
-                        <a:t>本機開發</a:t>
+                        <a:t>區網 HTTPS</a:t>
                       </a:r>
                       <a:endParaRPr lang="en-US" sz="1500" dirty="0">
                         <a:latin typeface="Microsoft JhengHei" charset="0"/>
@@ -3713,7 +3713,7 @@
                           <a:ea typeface="Microsoft JhengHei" pitchFamily="34" charset="-122"/>
                           <a:cs typeface="Microsoft JhengHei" pitchFamily="34" charset="-120"/>
                         </a:rPr>
-                        <a:t>http://127.0.0.1:3847</a:t>
+                        <a:t>https://伺服器IP:3848</a:t>
                       </a:r>
                       <a:endParaRPr lang="en-US" sz="1500" dirty="0">
                         <a:latin typeface="Microsoft JhengHei" charset="0"/>
@@ -4127,7 +4127,7 @@
                 <a:ea typeface="Microsoft JhengHei" pitchFamily="34" charset="-122"/>
                 <a:cs typeface="Microsoft JhengHei" pitchFamily="34" charset="-120"/>
               </a:rPr>
-              <a:t>CatsHome 線上簽核  ·  2 / 12</a:t>
+              <a:t>線上簽核系統  ·  2 / 12</a:t>
             </a:r>
             <a:endParaRPr lang="en-US" sz="1100" dirty="0"/>
           </a:p>
@@ -4983,7 +4983,7 @@
                 <a:ea typeface="Microsoft JhengHei" pitchFamily="34" charset="-122"/>
                 <a:cs typeface="Microsoft JhengHei" pitchFamily="34" charset="-120"/>
               </a:rPr>
-              <a:t>CatsHome 線上簽核  ·  3 / 12</a:t>
+              <a:t>線上簽核系統  ·  3 / 12</a:t>
             </a:r>
             <a:endParaRPr lang="en-US" sz="1100" dirty="0"/>
           </a:p>
@@ -5766,7 +5766,7 @@
                 <a:ea typeface="Microsoft JhengHei" pitchFamily="34" charset="-122"/>
                 <a:cs typeface="Microsoft JhengHei" pitchFamily="34" charset="-120"/>
               </a:rPr>
-              <a:t>CatsHome 線上簽核  ·  4 / 12</a:t>
+              <a:t>線上簽核系統  ·  4 / 12</a:t>
             </a:r>
             <a:endParaRPr lang="en-US" sz="1100" dirty="0"/>
           </a:p>
@@ -6807,7 +6807,7 @@
                 <a:ea typeface="Microsoft JhengHei" pitchFamily="34" charset="-122"/>
                 <a:cs typeface="Microsoft JhengHei" pitchFamily="34" charset="-120"/>
               </a:rPr>
-              <a:t>CatsHome 線上簽核  ·  5 / 12</a:t>
+              <a:t>線上簽核系統  ·  5 / 12</a:t>
             </a:r>
             <a:endParaRPr lang="en-US" sz="1100" dirty="0"/>
           </a:p>
@@ -7803,7 +7803,7 @@
                 <a:ea typeface="Microsoft JhengHei" pitchFamily="34" charset="-122"/>
                 <a:cs typeface="Microsoft JhengHei" pitchFamily="34" charset="-120"/>
               </a:rPr>
-              <a:t>CatsHome 線上簽核  ·  6 / 12</a:t>
+              <a:t>線上簽核系統  ·  6 / 12</a:t>
             </a:r>
             <a:endParaRPr lang="en-US" sz="1100" dirty="0"/>
           </a:p>
@@ -8556,7 +8556,7 @@
                 <a:ea typeface="Microsoft JhengHei" pitchFamily="34" charset="-122"/>
                 <a:cs typeface="Microsoft JhengHei" pitchFamily="34" charset="-120"/>
               </a:rPr>
-              <a:t>CatsHome 線上簽核  ·  7 / 12</a:t>
+              <a:t>線上簽核系統  ·  7 / 12</a:t>
             </a:r>
             <a:endParaRPr lang="en-US" sz="1100" dirty="0"/>
           </a:p>
@@ -8813,7 +8813,7 @@
                 <a:ea typeface="Microsoft JhengHei" pitchFamily="34" charset="-122"/>
                 <a:cs typeface="Microsoft JhengHei" pitchFamily="34" charset="-120"/>
               </a:rPr>
-              <a:t>CatsHome 線上簽核  ·  8 / 12</a:t>
+              <a:t>線上簽核系統  ·  8 / 12</a:t>
             </a:r>
             <a:endParaRPr lang="en-US" sz="1100" dirty="0"/>
           </a:p>
@@ -9257,7 +9257,7 @@
                 <a:ea typeface="Microsoft JhengHei" pitchFamily="34" charset="-122"/>
                 <a:cs typeface="Microsoft JhengHei" pitchFamily="34" charset="-120"/>
               </a:rPr>
-              <a:t>CatsHome 線上簽核  ·  9 / 12</a:t>
+              <a:t>線上簽核系統  ·  9 / 12</a:t>
             </a:r>
             <a:endParaRPr lang="en-US" sz="1100" dirty="0"/>
           </a:p>

</xml_diff>